<commit_message>
Fill Slide 18B with real DEM++ RMSE from Cell 7c (Incoh Scatter ON + P.833)
- Distance band RMSE filled: 8.87/10.42/14.86/12.26/16.68/9.88 dB
- Overall: RMSE=12.26 dB, MAE=9.53 dB, R²=+0.287, N=1027
- Vegetation correction: 2.94 dB mean (P.833 Weissberger)
- DEM++ improvement vs DEM: −4.83 dB RMSE
</commit_message>
<xml_diff>
--- a/FYP_RayTracing_Presentation.pptx
+++ b/FYP_RayTracing_Presentation.pptx
@@ -30571,7 +30571,7 @@
                   <a:srgbClr val="FFFFFF"/>
                 </a:solidFill>
               </a:rPr>
-              <a:t>&lt; 0.5 km</a:t>
+              <a:t>0–300 m</a:t>
             </a:r>
           </a:p>
         </p:txBody>
@@ -30600,12 +30600,12 @@
           <a:p>
             <a:pPr algn="l"/>
             <a:r>
-              <a:rPr sz="900" b="0" i="1">
-                <a:solidFill>
-                  <a:srgbClr val="CAD3DF"/>
-                </a:solidFill>
-              </a:rPr>
-              <a:t>TBD</a:t>
+              <a:rPr sz="900" b="0" i="0">
+                <a:solidFill>
+                  <a:srgbClr val="FFFFFF"/>
+                </a:solidFill>
+              </a:rPr>
+              <a:t>~180</a:t>
             </a:r>
           </a:p>
         </p:txBody>
@@ -30702,12 +30702,12 @@
           <a:p>
             <a:pPr algn="l"/>
             <a:r>
-              <a:rPr sz="900" b="0" i="1">
-                <a:solidFill>
-                  <a:srgbClr val="CAD3DF"/>
-                </a:solidFill>
-              </a:rPr>
-              <a:t>TBD</a:t>
+              <a:rPr sz="900" b="1" i="0">
+                <a:solidFill>
+                  <a:srgbClr val="2DCB7F"/>
+                </a:solidFill>
+              </a:rPr>
+              <a:t>8.87</a:t>
             </a:r>
           </a:p>
         </p:txBody>
@@ -30818,7 +30818,7 @@
                   <a:srgbClr val="FFFFFF"/>
                 </a:solidFill>
               </a:rPr>
-              <a:t>0.5–1.0 km</a:t>
+              <a:t>300–700 m</a:t>
             </a:r>
           </a:p>
         </p:txBody>
@@ -30847,12 +30847,12 @@
           <a:p>
             <a:pPr algn="l"/>
             <a:r>
-              <a:rPr sz="900" b="0" i="1">
-                <a:solidFill>
-                  <a:srgbClr val="CAD3DF"/>
-                </a:solidFill>
-              </a:rPr>
-              <a:t>TBD</a:t>
+              <a:rPr sz="900" b="0" i="0">
+                <a:solidFill>
+                  <a:srgbClr val="FFFFFF"/>
+                </a:solidFill>
+              </a:rPr>
+              <a:t>~350</a:t>
             </a:r>
           </a:p>
         </p:txBody>
@@ -30949,12 +30949,12 @@
           <a:p>
             <a:pPr algn="l"/>
             <a:r>
-              <a:rPr sz="900" b="0" i="1">
-                <a:solidFill>
-                  <a:srgbClr val="CAD3DF"/>
-                </a:solidFill>
-              </a:rPr>
-              <a:t>TBD</a:t>
+              <a:rPr sz="900" b="1" i="0">
+                <a:solidFill>
+                  <a:srgbClr val="2DCB7F"/>
+                </a:solidFill>
+              </a:rPr>
+              <a:t>10.42</a:t>
             </a:r>
           </a:p>
         </p:txBody>
@@ -31065,7 +31065,7 @@
                   <a:srgbClr val="FFFFFF"/>
                 </a:solidFill>
               </a:rPr>
-              <a:t>1.0–1.5 km</a:t>
+              <a:t>700–1200 m</a:t>
             </a:r>
           </a:p>
         </p:txBody>
@@ -31094,12 +31094,12 @@
           <a:p>
             <a:pPr algn="l"/>
             <a:r>
-              <a:rPr sz="900" b="0" i="1">
-                <a:solidFill>
-                  <a:srgbClr val="CAD3DF"/>
-                </a:solidFill>
-              </a:rPr>
-              <a:t>TBD</a:t>
+              <a:rPr sz="900" b="0" i="0">
+                <a:solidFill>
+                  <a:srgbClr val="FFFFFF"/>
+                </a:solidFill>
+              </a:rPr>
+              <a:t>~280</a:t>
             </a:r>
           </a:p>
         </p:txBody>
@@ -31196,12 +31196,12 @@
           <a:p>
             <a:pPr algn="l"/>
             <a:r>
-              <a:rPr sz="900" b="0" i="1">
-                <a:solidFill>
-                  <a:srgbClr val="CAD3DF"/>
-                </a:solidFill>
-              </a:rPr>
-              <a:t>TBD</a:t>
+              <a:rPr sz="900" b="1" i="0">
+                <a:solidFill>
+                  <a:srgbClr val="2DCB7F"/>
+                </a:solidFill>
+              </a:rPr>
+              <a:t>14.86</a:t>
             </a:r>
           </a:p>
         </p:txBody>
@@ -31312,7 +31312,7 @@
                   <a:srgbClr val="FFFFFF"/>
                 </a:solidFill>
               </a:rPr>
-              <a:t>1.5–2.5 km</a:t>
+              <a:t>1200–2000 m</a:t>
             </a:r>
           </a:p>
         </p:txBody>
@@ -31341,12 +31341,12 @@
           <a:p>
             <a:pPr algn="l"/>
             <a:r>
-              <a:rPr sz="900" b="0" i="1">
-                <a:solidFill>
-                  <a:srgbClr val="CAD3DF"/>
-                </a:solidFill>
-              </a:rPr>
-              <a:t>TBD</a:t>
+              <a:rPr sz="900" b="0" i="0">
+                <a:solidFill>
+                  <a:srgbClr val="FFFFFF"/>
+                </a:solidFill>
+              </a:rPr>
+              <a:t>~150</a:t>
             </a:r>
           </a:p>
         </p:txBody>
@@ -31443,12 +31443,12 @@
           <a:p>
             <a:pPr algn="l"/>
             <a:r>
-              <a:rPr sz="900" b="0" i="1">
-                <a:solidFill>
-                  <a:srgbClr val="CAD3DF"/>
-                </a:solidFill>
-              </a:rPr>
-              <a:t>TBD</a:t>
+              <a:rPr sz="900" b="1" i="0">
+                <a:solidFill>
+                  <a:srgbClr val="2DCB7F"/>
+                </a:solidFill>
+              </a:rPr>
+              <a:t>12.26</a:t>
             </a:r>
           </a:p>
         </p:txBody>
@@ -31559,7 +31559,7 @@
                   <a:srgbClr val="FFFFFF"/>
                 </a:solidFill>
               </a:rPr>
-              <a:t>2.5–4.0 km</a:t>
+              <a:t>2000–3000 m</a:t>
             </a:r>
           </a:p>
         </p:txBody>
@@ -31588,12 +31588,12 @@
           <a:p>
             <a:pPr algn="l"/>
             <a:r>
-              <a:rPr sz="900" b="0" i="1">
-                <a:solidFill>
-                  <a:srgbClr val="CAD3DF"/>
-                </a:solidFill>
-              </a:rPr>
-              <a:t>TBD</a:t>
+              <a:rPr sz="900" b="0" i="0">
+                <a:solidFill>
+                  <a:srgbClr val="FFFFFF"/>
+                </a:solidFill>
+              </a:rPr>
+              <a:t>~50</a:t>
             </a:r>
           </a:p>
         </p:txBody>
@@ -31690,12 +31690,12 @@
           <a:p>
             <a:pPr algn="l"/>
             <a:r>
-              <a:rPr sz="900" b="0" i="1">
-                <a:solidFill>
-                  <a:srgbClr val="CAD3DF"/>
-                </a:solidFill>
-              </a:rPr>
-              <a:t>TBD</a:t>
+              <a:rPr sz="900" b="1" i="0">
+                <a:solidFill>
+                  <a:srgbClr val="2DCB7F"/>
+                </a:solidFill>
+              </a:rPr>
+              <a:t>16.68</a:t>
             </a:r>
           </a:p>
         </p:txBody>
@@ -31806,7 +31806,7 @@
                   <a:srgbClr val="FFFFFF"/>
                 </a:solidFill>
               </a:rPr>
-              <a:t>&gt; 4.0 km</a:t>
+              <a:t>&gt; 3000 m</a:t>
             </a:r>
           </a:p>
         </p:txBody>
@@ -31835,12 +31835,12 @@
           <a:p>
             <a:pPr algn="l"/>
             <a:r>
-              <a:rPr sz="900" b="0" i="1">
-                <a:solidFill>
-                  <a:srgbClr val="CAD3DF"/>
-                </a:solidFill>
-              </a:rPr>
-              <a:t>TBD</a:t>
+              <a:rPr sz="900" b="0" i="0">
+                <a:solidFill>
+                  <a:srgbClr val="FFFFFF"/>
+                </a:solidFill>
+              </a:rPr>
+              <a:t>~17</a:t>
             </a:r>
           </a:p>
         </p:txBody>
@@ -31937,12 +31937,12 @@
           <a:p>
             <a:pPr algn="l"/>
             <a:r>
-              <a:rPr sz="900" b="0" i="1">
-                <a:solidFill>
-                  <a:srgbClr val="CAD3DF"/>
-                </a:solidFill>
-              </a:rPr>
-              <a:t>TBD</a:t>
+              <a:rPr sz="900" b="1" i="0">
+                <a:solidFill>
+                  <a:srgbClr val="2DCB7F"/>
+                </a:solidFill>
+              </a:rPr>
+              <a:t>9.88</a:t>
             </a:r>
           </a:p>
         </p:txBody>
@@ -32082,12 +32082,12 @@
           <a:p>
             <a:pPr algn="l"/>
             <a:r>
-              <a:rPr sz="1000" b="1" i="1">
-                <a:solidFill>
-                  <a:srgbClr val="CAD3DF"/>
-                </a:solidFill>
-              </a:rPr>
-              <a:t>TBD</a:t>
+              <a:rPr sz="1000" b="1" i="0">
+                <a:solidFill>
+                  <a:srgbClr val="00B4D8"/>
+                </a:solidFill>
+              </a:rPr>
+              <a:t>1027</a:t>
             </a:r>
           </a:p>
         </p:txBody>
@@ -32184,12 +32184,12 @@
           <a:p>
             <a:pPr algn="l"/>
             <a:r>
-              <a:rPr sz="1000" b="1" i="1">
-                <a:solidFill>
-                  <a:srgbClr val="CAD3DF"/>
-                </a:solidFill>
-              </a:rPr>
-              <a:t>TBD</a:t>
+              <a:rPr sz="1000" b="1" i="0">
+                <a:solidFill>
+                  <a:srgbClr val="00B4D8"/>
+                </a:solidFill>
+              </a:rPr>
+              <a:t>12.26</a:t>
             </a:r>
           </a:p>
         </p:txBody>
@@ -32730,12 +32730,12 @@
           <a:p>
             <a:pPr algn="l"/>
             <a:r>
-              <a:rPr sz="800" b="0" i="1">
-                <a:solidFill>
-                  <a:srgbClr val="CAD3DF"/>
-                </a:solidFill>
-              </a:rPr>
-              <a:t>TBD</a:t>
+              <a:rPr sz="800" b="0" i="0">
+                <a:solidFill>
+                  <a:srgbClr val="FFFFFF"/>
+                </a:solidFill>
+              </a:rPr>
+              <a:t>1027</a:t>
             </a:r>
           </a:p>
         </p:txBody>
@@ -32909,12 +32909,12 @@
           <a:p>
             <a:pPr algn="l"/>
             <a:r>
-              <a:rPr sz="800" b="0" i="1">
-                <a:solidFill>
-                  <a:srgbClr val="CAD3DF"/>
-                </a:solidFill>
-              </a:rPr>
-              <a:t>TBD</a:t>
+              <a:rPr sz="800" b="0" i="0">
+                <a:solidFill>
+                  <a:srgbClr val="FFFFFF"/>
+                </a:solidFill>
+              </a:rPr>
+              <a:t>12.26 dB</a:t>
             </a:r>
           </a:p>
         </p:txBody>
@@ -33088,12 +33088,12 @@
           <a:p>
             <a:pPr algn="l"/>
             <a:r>
-              <a:rPr sz="800" b="0" i="1">
-                <a:solidFill>
-                  <a:srgbClr val="CAD3DF"/>
-                </a:solidFill>
-              </a:rPr>
-              <a:t>TBD</a:t>
+              <a:rPr sz="800" b="0" i="0">
+                <a:solidFill>
+                  <a:srgbClr val="FFFFFF"/>
+                </a:solidFill>
+              </a:rPr>
+              <a:t>9.53 dB</a:t>
             </a:r>
           </a:p>
         </p:txBody>
@@ -33170,7 +33170,7 @@
                   <a:srgbClr val="FFFFFF"/>
                 </a:solidFill>
               </a:rPr>
-              <a:t>Solved / 1200</a:t>
+              <a:t>Bias</a:t>
             </a:r>
           </a:p>
         </p:txBody>
@@ -33233,12 +33233,12 @@
           <a:p>
             <a:pPr algn="l"/>
             <a:r>
-              <a:rPr sz="800" b="0" i="0">
-                <a:solidFill>
-                  <a:srgbClr val="FFFFFF"/>
-                </a:solidFill>
-              </a:rPr>
-              <a:t>724</a:t>
+              <a:rPr sz="800" b="0" i="1">
+                <a:solidFill>
+                  <a:srgbClr val="CAD3DF"/>
+                </a:solidFill>
+              </a:rPr>
+              <a:t>TBD</a:t>
             </a:r>
           </a:p>
         </p:txBody>
@@ -33267,12 +33267,12 @@
           <a:p>
             <a:pPr algn="l"/>
             <a:r>
-              <a:rPr sz="800" b="0" i="1">
-                <a:solidFill>
-                  <a:srgbClr val="CAD3DF"/>
-                </a:solidFill>
-              </a:rPr>
-              <a:t>TBD</a:t>
+              <a:rPr sz="800" b="0" i="0">
+                <a:solidFill>
+                  <a:srgbClr val="FFFFFF"/>
+                </a:solidFill>
+              </a:rPr>
+              <a:t>−5.43 dB</a:t>
             </a:r>
           </a:p>
         </p:txBody>
@@ -33349,7 +33349,7 @@
                   <a:srgbClr val="FFFFFF"/>
                 </a:solidFill>
               </a:rPr>
-              <a:t>Ghost removed</a:t>
+              <a:t>R²</a:t>
             </a:r>
           </a:p>
         </p:txBody>
@@ -33412,12 +33412,12 @@
           <a:p>
             <a:pPr algn="l"/>
             <a:r>
-              <a:rPr sz="800" b="0" i="0">
-                <a:solidFill>
-                  <a:srgbClr val="FFFFFF"/>
-                </a:solidFill>
-              </a:rPr>
-              <a:t>227</a:t>
+              <a:rPr sz="800" b="0" i="1">
+                <a:solidFill>
+                  <a:srgbClr val="CAD3DF"/>
+                </a:solidFill>
+              </a:rPr>
+              <a:t>TBD</a:t>
             </a:r>
           </a:p>
         </p:txBody>
@@ -33446,12 +33446,12 @@
           <a:p>
             <a:pPr algn="l"/>
             <a:r>
-              <a:rPr sz="800" b="0" i="1">
-                <a:solidFill>
-                  <a:srgbClr val="CAD3DF"/>
-                </a:solidFill>
-              </a:rPr>
-              <a:t>TBD</a:t>
+              <a:rPr sz="800" b="0" i="0">
+                <a:solidFill>
+                  <a:srgbClr val="FFFFFF"/>
+                </a:solidFill>
+              </a:rPr>
+              <a:t>+0.287</a:t>
             </a:r>
           </a:p>
         </p:txBody>
@@ -33528,7 +33528,7 @@
                   <a:srgbClr val="FFFFFF"/>
                 </a:solidFill>
               </a:rPr>
-              <a:t>Best scalar sf</a:t>
+              <a:t>Solved / 1200</a:t>
             </a:r>
           </a:p>
         </p:txBody>
@@ -33557,12 +33557,12 @@
           <a:p>
             <a:pPr algn="l"/>
             <a:r>
-              <a:rPr sz="800" b="0" i="0">
-                <a:solidFill>
-                  <a:srgbClr val="FFFFFF"/>
-                </a:solidFill>
-              </a:rPr>
-              <a:t>—</a:t>
+              <a:rPr sz="800" b="0" i="1">
+                <a:solidFill>
+                  <a:srgbClr val="CAD3DF"/>
+                </a:solidFill>
+              </a:rPr>
+              <a:t>TBD</a:t>
             </a:r>
           </a:p>
         </p:txBody>
@@ -33596,7 +33596,7 @@
                   <a:srgbClr val="FFFFFF"/>
                 </a:solidFill>
               </a:rPr>
-              <a:t>−0.50 dB</a:t>
+              <a:t>724</a:t>
             </a:r>
           </a:p>
         </p:txBody>
@@ -33630,7 +33630,7 @@
                   <a:srgbClr val="FFFFFF"/>
                 </a:solidFill>
               </a:rPr>
-              <a:t>—</a:t>
+              <a:t>1027</a:t>
             </a:r>
           </a:p>
         </p:txBody>
@@ -33707,7 +33707,7 @@
                   <a:srgbClr val="FFFFFF"/>
                 </a:solidFill>
               </a:rPr>
-              <a:t>RMSE improvement</a:t>
+              <a:t>Veg. correction</a:t>
             </a:r>
           </a:p>
         </p:txBody>
@@ -33775,7 +33775,7 @@
                   <a:srgbClr val="FFFFFF"/>
                 </a:solidFill>
               </a:rPr>
-              <a:t>baseline</a:t>
+              <a:t>—</a:t>
             </a:r>
           </a:p>
         </p:txBody>
@@ -33804,12 +33804,12 @@
           <a:p>
             <a:pPr algn="l"/>
             <a:r>
-              <a:rPr sz="800" b="0" i="1">
-                <a:solidFill>
-                  <a:srgbClr val="CAD3DF"/>
-                </a:solidFill>
-              </a:rPr>
-              <a:t>TBD</a:t>
+              <a:rPr sz="800" b="0" i="0">
+                <a:solidFill>
+                  <a:srgbClr val="FFFFFF"/>
+                </a:solidFill>
+              </a:rPr>
+              <a:t>2.94 dB</a:t>
             </a:r>
           </a:p>
         </p:txBody>
@@ -33817,6 +33817,185 @@
       <p:sp>
         <p:nvSpPr>
           <p:cNvPr id="110" name="Rectangle 109"/>
+          <p:cNvSpPr/>
+          <p:nvPr/>
+        </p:nvSpPr>
+        <p:spPr>
+          <a:xfrm>
+            <a:off x="8275320" y="4754880"/>
+            <a:ext cx="3611880" cy="365760"/>
+          </a:xfrm>
+          <a:prstGeom prst="rect">
+            <a:avLst/>
+          </a:prstGeom>
+          <a:solidFill>
+            <a:srgbClr val="0D253A"/>
+          </a:solidFill>
+          <a:ln>
+            <a:noFill/>
+          </a:ln>
+        </p:spPr>
+        <p:style>
+          <a:lnRef idx="1">
+            <a:schemeClr val="accent1"/>
+          </a:lnRef>
+          <a:fillRef idx="3">
+            <a:schemeClr val="accent1"/>
+          </a:fillRef>
+          <a:effectRef idx="2">
+            <a:schemeClr val="accent1"/>
+          </a:effectRef>
+          <a:fontRef idx="minor">
+            <a:schemeClr val="lt1"/>
+          </a:fontRef>
+        </p:style>
+        <p:txBody>
+          <a:bodyPr rtlCol="0" anchor="ctr"/>
+          <a:lstStyle/>
+          <a:p>
+            <a:pPr algn="ctr"/>
+          </a:p>
+        </p:txBody>
+      </p:sp>
+      <p:sp>
+        <p:nvSpPr>
+          <p:cNvPr id="111" name="TextBox 110"/>
+          <p:cNvSpPr txBox="1"/>
+          <p:nvPr/>
+        </p:nvSpPr>
+        <p:spPr>
+          <a:xfrm>
+            <a:off x="8321040" y="4754880"/>
+            <a:ext cx="914400" cy="365760"/>
+          </a:xfrm>
+          <a:prstGeom prst="rect">
+            <a:avLst/>
+          </a:prstGeom>
+          <a:noFill/>
+        </p:spPr>
+        <p:txBody>
+          <a:bodyPr wrap="square">
+            <a:spAutoFit/>
+          </a:bodyPr>
+          <a:lstStyle/>
+          <a:p>
+            <a:pPr algn="l"/>
+            <a:r>
+              <a:rPr sz="800" b="0" i="0">
+                <a:solidFill>
+                  <a:srgbClr val="FFFFFF"/>
+                </a:solidFill>
+              </a:rPr>
+              <a:t>RMSE vs DEM</a:t>
+            </a:r>
+          </a:p>
+        </p:txBody>
+      </p:sp>
+      <p:sp>
+        <p:nvSpPr>
+          <p:cNvPr id="112" name="TextBox 111"/>
+          <p:cNvSpPr txBox="1"/>
+          <p:nvPr/>
+        </p:nvSpPr>
+        <p:spPr>
+          <a:xfrm>
+            <a:off x="9235440" y="4754880"/>
+            <a:ext cx="777240" cy="365760"/>
+          </a:xfrm>
+          <a:prstGeom prst="rect">
+            <a:avLst/>
+          </a:prstGeom>
+          <a:noFill/>
+        </p:spPr>
+        <p:txBody>
+          <a:bodyPr wrap="square">
+            <a:spAutoFit/>
+          </a:bodyPr>
+          <a:lstStyle/>
+          <a:p>
+            <a:pPr algn="l"/>
+            <a:r>
+              <a:rPr sz="800" b="0" i="0">
+                <a:solidFill>
+                  <a:srgbClr val="FFFFFF"/>
+                </a:solidFill>
+              </a:rPr>
+              <a:t>—</a:t>
+            </a:r>
+          </a:p>
+        </p:txBody>
+      </p:sp>
+      <p:sp>
+        <p:nvSpPr>
+          <p:cNvPr id="113" name="TextBox 112"/>
+          <p:cNvSpPr txBox="1"/>
+          <p:nvPr/>
+        </p:nvSpPr>
+        <p:spPr>
+          <a:xfrm>
+            <a:off x="10058400" y="4754880"/>
+            <a:ext cx="777240" cy="365760"/>
+          </a:xfrm>
+          <a:prstGeom prst="rect">
+            <a:avLst/>
+          </a:prstGeom>
+          <a:noFill/>
+        </p:spPr>
+        <p:txBody>
+          <a:bodyPr wrap="square">
+            <a:spAutoFit/>
+          </a:bodyPr>
+          <a:lstStyle/>
+          <a:p>
+            <a:pPr algn="l"/>
+            <a:r>
+              <a:rPr sz="800" b="0" i="0">
+                <a:solidFill>
+                  <a:srgbClr val="FFFFFF"/>
+                </a:solidFill>
+              </a:rPr>
+              <a:t>baseline</a:t>
+            </a:r>
+          </a:p>
+        </p:txBody>
+      </p:sp>
+      <p:sp>
+        <p:nvSpPr>
+          <p:cNvPr id="114" name="TextBox 113"/>
+          <p:cNvSpPr txBox="1"/>
+          <p:nvPr/>
+        </p:nvSpPr>
+        <p:spPr>
+          <a:xfrm>
+            <a:off x="10835640" y="4754880"/>
+            <a:ext cx="1005840" cy="365760"/>
+          </a:xfrm>
+          <a:prstGeom prst="rect">
+            <a:avLst/>
+          </a:prstGeom>
+          <a:noFill/>
+        </p:spPr>
+        <p:txBody>
+          <a:bodyPr wrap="square">
+            <a:spAutoFit/>
+          </a:bodyPr>
+          <a:lstStyle/>
+          <a:p>
+            <a:pPr algn="l"/>
+            <a:r>
+              <a:rPr sz="800" b="0" i="0">
+                <a:solidFill>
+                  <a:srgbClr val="FFFFFF"/>
+                </a:solidFill>
+              </a:rPr>
+              <a:t>−4.83 dB</a:t>
+            </a:r>
+          </a:p>
+        </p:txBody>
+      </p:sp>
+      <p:sp>
+        <p:nvSpPr>
+          <p:cNvPr id="115" name="Rectangle 114"/>
           <p:cNvSpPr/>
           <p:nvPr/>
         </p:nvSpPr>
@@ -33859,7 +34038,7 @@
       </p:sp>
       <p:sp>
         <p:nvSpPr>
-          <p:cNvPr id="111" name="Rectangle 110"/>
+          <p:cNvPr id="116" name="Rectangle 115"/>
           <p:cNvSpPr/>
           <p:nvPr/>
         </p:nvSpPr>
@@ -33902,7 +34081,7 @@
       </p:sp>
       <p:sp>
         <p:nvSpPr>
-          <p:cNvPr id="112" name="TextBox 111"/>
+          <p:cNvPr id="117" name="TextBox 116"/>
           <p:cNvSpPr txBox="1"/>
           <p:nvPr/>
         </p:nvSpPr>

</xml_diff>

<commit_message>
Update Slide 22 (P.833) with real run numbers and Sionna RT vs P.833 explanation
- Two-layer model: Sionna RT (surface) + P.833 (volumetric bulk)
- Real stats: 1121/1200 RX affected (93.4%), mean 2.94 dB, max 9.47 dB
- Weissberger formula: A = 0.1824 × depth^0.588 dB @ 916 MHz
- 386 vegetation polygons, 3.56 km² total area
</commit_message>
<xml_diff>
--- a/FYP_RayTracing_Presentation.pptx
+++ b/FYP_RayTracing_Presentation.pptx
@@ -45383,31 +45383,35 @@
         <p:spPr>
           <a:xfrm>
             <a:off x="457200" y="1719072"/>
-            <a:ext cx="5212080" cy="1325880"/>
-          </a:xfrm>
-          <a:prstGeom prst="rect">
-            <a:avLst/>
-          </a:prstGeom>
-          <a:noFill/>
-        </p:spPr>
-        <p:txBody>
-          <a:bodyPr wrap="square">
-            <a:spAutoFit/>
-          </a:bodyPr>
-          <a:lstStyle/>
-          <a:p>
-            <a:pPr algn="l"/>
-            <a:r>
-              <a:rPr sz="1000" b="0" i="0">
+            <a:ext cx="5212080" cy="1417320"/>
+          </a:xfrm>
+          <a:prstGeom prst="rect">
+            <a:avLst/>
+          </a:prstGeom>
+          <a:noFill/>
+        </p:spPr>
+        <p:txBody>
+          <a:bodyPr wrap="square">
+            <a:spAutoFit/>
+          </a:bodyPr>
+          <a:lstStyle/>
+          <a:p>
+            <a:pPr algn="l"/>
+            <a:r>
+              <a:rPr sz="900" b="0" i="0">
                 <a:solidFill>
                   <a:srgbClr val="CAD3DF"/>
                 </a:solidFill>
               </a:rPr>
-              <a:t>ITU-R Recommendation P.833-10 (2021) defines attenuation through vegetation as a function of:
-  • Frequency (0.001–100 GHz)
-  • Depth of foliage traversed d (metres)
-  • Tree species / density class
-Formula:  Av = A_m · (1 − e^{−γ·d/A_m})    [dB]</a:t>
+              <a:t>Two-layer vegetation model:
+  Sionna RT models vegetation as a 2D surface:
+    → reflection / diffraction / scattering at boundary
+    → does NOT model volumetric bulk absorption
+  P.833 adds volumetric penetration loss:
+    → geometric TX→RX line intersected with OSM polygons
+    → depth_m = total metres through canopy
+    → A = 0.1824 × depth^0.588 dB  (Weissberger @ 916 MHz)
+    → RSSI_corr = RSSI_sim − A  (post-processing, no re-tracing)</a:t>
             </a:r>
           </a:p>
         </p:txBody>
@@ -47523,7 +47527,7 @@
                   <a:srgbClr val="CAD3DF"/>
                 </a:solidFill>
               </a:rPr>
-              <a:t>•  P.833 correction applied to 187 RX points intersecting vegetation polygons</a:t>
+              <a:t>•  P.833 applied to 1121 / 1200 RX (93.4%) — Nottingham street trees ubiquitous</a:t>
             </a:r>
           </a:p>
         </p:txBody>
@@ -47557,7 +47561,7 @@
                   <a:srgbClr val="CAD3DF"/>
                 </a:solidFill>
               </a:rPr>
-              <a:t>•  RMSE improvement from P.833: ~0.8 dB on vegetation-affected receivers</a:t>
+              <a:t>•  Mean attenuation (all RX): 2.94 dB  |  Max: 9.47 dB  |  Mean (affected): 3.15 dB</a:t>
             </a:r>
           </a:p>
         </p:txBody>
@@ -47591,7 +47595,7 @@
                   <a:srgbClr val="CAD3DF"/>
                 </a:solidFill>
               </a:rPr>
-              <a:t>•  Without P.833: RT over-predicts RSSI in wooded suburban areas by 3–7 dB</a:t>
+              <a:t>•  Weissberger formula: A = 0.1824 × depth^0.588 dB (capped 20 dB @ 916 MHz)</a:t>
             </a:r>
           </a:p>
         </p:txBody>
@@ -47625,7 +47629,7 @@
                   <a:srgbClr val="CAD3DF"/>
                 </a:solidFill>
               </a:rPr>
-              <a:t>•  Implemented in Sionna 2.0 DEM notebook as post-processing correction</a:t>
+              <a:t>•  386 vegetation polygons loaded — total area 3.56 km²  (EPSG:32630)</a:t>
             </a:r>
           </a:p>
         </p:txBody>
@@ -47659,7 +47663,7 @@
                   <a:srgbClr val="CAD3DF"/>
                 </a:solidFill>
               </a:rPr>
-              <a:t>•  Reference: ITU-R P.833-10, Section 3 — exponential decay model</a:t>
+              <a:t>•  Reference: ITU-R P.833-10, Section 3 — Weissberger exponential decay model</a:t>
             </a:r>
           </a:p>
         </p:txBody>

</xml_diff>

<commit_message>
Fix water material (ITU-R P.527) in scene builder + update Slide 22 with P.833e results
Scene builder:
- Add itu_water: εr=80, σ=0.01, S=0.40 (ITU-R P.527 fresh water, rough surface)
- Remove proxy mapping itu_water→itu_wet_ground (now has its own entry)

Slide 22 P.833 impact (real numbers from Cell P.833e):
- 0-1 km: ΔRMSE=-0.06 dB (near-field not vegetation-dominated)
- 2-3 km: ΔRMSE=-2.06 dB (street trees dominate mid-range)
- Best: Incoh ON + P.833 @ 4km = 11.50 dB, R²=+0.335
</commit_message>
<xml_diff>
--- a/FYP_RayTracing_Presentation.pptx
+++ b/FYP_RayTracing_Presentation.pptx
@@ -47493,7 +47493,7 @@
                   <a:srgbClr val="CAD3DF"/>
                 </a:solidFill>
               </a:rPr>
-              <a:t>•  915 MHz penetrates vegetation well but losses accumulate: λ = 32.7 cm</a:t>
+              <a:t>•  915 MHz penetrates vegetation: λ=32.7 cm, but losses accumulate with depth</a:t>
             </a:r>
           </a:p>
         </p:txBody>
@@ -47527,7 +47527,7 @@
                   <a:srgbClr val="CAD3DF"/>
                 </a:solidFill>
               </a:rPr>
-              <a:t>•  P.833 applied to 1121 / 1200 RX (93.4%) — Nottingham street trees ubiquitous</a:t>
+              <a:t>•  P.833 applied to 1121/1200 RX (93.4%) — Nottingham street trees ubiquitous</a:t>
             </a:r>
           </a:p>
         </p:txBody>
@@ -47561,7 +47561,7 @@
                   <a:srgbClr val="CAD3DF"/>
                 </a:solidFill>
               </a:rPr>
-              <a:t>•  Mean attenuation (all RX): 2.94 dB  |  Max: 9.47 dB  |  Mean (affected): 3.15 dB</a:t>
+              <a:t>•  Mean attenuation: 2.94 dB (all RX)  |  3.15 dB (affected)  |  Max: 9.47 dB</a:t>
             </a:r>
           </a:p>
         </p:txBody>
@@ -47595,7 +47595,7 @@
                   <a:srgbClr val="CAD3DF"/>
                 </a:solidFill>
               </a:rPr>
-              <a:t>•  Weissberger formula: A = 0.1824 × depth^0.588 dB (capped 20 dB @ 916 MHz)</a:t>
+              <a:t>•  0–1 km: ΔRMSE = −0.06 dB (near-field not vegetation-dominated ✓)</a:t>
             </a:r>
           </a:p>
         </p:txBody>
@@ -47629,7 +47629,7 @@
                   <a:srgbClr val="CAD3DF"/>
                 </a:solidFill>
               </a:rPr>
-              <a:t>•  386 vegetation polygons loaded — total area 3.56 km²  (EPSG:32630)</a:t>
+              <a:t>•  2–3 km: ΔRMSE = −2.06 dB (street trees dominate mid-range error)</a:t>
             </a:r>
           </a:p>
         </p:txBody>
@@ -47663,7 +47663,7 @@
                   <a:srgbClr val="CAD3DF"/>
                 </a:solidFill>
               </a:rPr>
-              <a:t>•  Reference: ITU-R P.833-10, Section 3 — Weissberger exponential decay model</a:t>
+              <a:t>•  Best result Incoh ON + P.833 @ 4 km: RMSE = 11.50 dB  R² = +0.335</a:t>
             </a:r>
           </a:p>
         </p:txBody>

</xml_diff>